<commit_message>
Bundle dashboard libraries locally for offline data rendering
</commit_message>
<xml_diff>
--- a/BC_Insights_Dashboard.pptx
+++ b/BC_Insights_Dashboard.pptx
@@ -1694,21 +1694,9 @@
           <a:bodyPr wrap="square" lIns="0" tIns="0" rIns="0" bIns="0" rtlCol="0" anchor="ctr"/>
           <a:lstStyle/>
           <a:p>
-            <a:pPr algn="l" indent="0" marL="0">
-              <a:buNone/>
-            </a:pPr>
-            <a:r>
-              <a:rPr lang="en-US" sz="1350" dirty="0">
-                <a:solidFill>
-                  <a:srgbClr val="4E9FD8"/>
-                </a:solidFill>
-                <a:latin typeface="Calibri" pitchFamily="34" charset="0"/>
-                <a:ea typeface="Calibri" pitchFamily="34" charset="-122"/>
-                <a:cs typeface="Calibri" pitchFamily="34" charset="-120"/>
-              </a:rPr>
-              <a:t>Supporting BC's strategic economic decisions — end to end</a:t>
-            </a:r>
-            <a:endParaRPr lang="en-US" sz="1350" dirty="0"/>
+            <a:r>
+              <a:t>Data-driven communication tool for internal BC economy monitoring and Look West progress assessment.</a:t>
+            </a:r>
           </a:p>
         </p:txBody>
       </p:sp>
@@ -1868,21 +1856,9 @@
           <a:bodyPr wrap="square" lIns="0" tIns="0" rIns="0" bIns="0" rtlCol="0" anchor="t"/>
           <a:lstStyle/>
           <a:p>
-            <a:pPr algn="l" indent="0" marL="0">
-              <a:buNone/>
-            </a:pPr>
-            <a:r>
-              <a:rPr lang="en-US" sz="1150" dirty="0">
-                <a:solidFill>
-                  <a:srgbClr val="5F7388"/>
-                </a:solidFill>
-                <a:latin typeface="Calibri" pitchFamily="34" charset="0"/>
-                <a:ea typeface="Calibri" pitchFamily="34" charset="-122"/>
-                <a:cs typeface="Calibri" pitchFamily="34" charset="-120"/>
-              </a:rPr>
-              <a:t>The BC Dashboard Hub consolidates economic intelligence into one executive-ready interface — no spreadsheet hunting, no context-switching.</a:t>
-            </a:r>
-            <a:endParaRPr lang="en-US" sz="1150" dirty="0"/>
+            <a:r>
+              <a:t>A data-driven communication platform that helps our team monitor BC economy signals and assess progress on Look West Strategy in one place.</a:t>
+            </a:r>
           </a:p>
         </p:txBody>
       </p:sp>
@@ -2177,21 +2153,9 @@
           <a:bodyPr wrap="square" lIns="0" tIns="0" rIns="0" bIns="0" rtlCol="0" anchor="t"/>
           <a:lstStyle/>
           <a:p>
-            <a:pPr algn="l" indent="0" marL="0">
-              <a:buNone/>
-            </a:pPr>
-            <a:r>
-              <a:rPr lang="en-US" sz="1200" b="1" dirty="0">
-                <a:solidFill>
-                  <a:srgbClr val="1C2A39"/>
-                </a:solidFill>
-                <a:latin typeface="Calibri" pitchFamily="34" charset="0"/>
-                <a:ea typeface="Calibri" pitchFamily="34" charset="-122"/>
-                <a:cs typeface="Calibri" pitchFamily="34" charset="-120"/>
-              </a:rPr>
-              <a:t>BC Macroeconomy</a:t>
-            </a:r>
-            <a:endParaRPr lang="en-US" sz="1200" dirty="0"/>
+            <a:r>
+              <a:t>BC Economy Snapshot</a:t>
+            </a:r>
           </a:p>
         </p:txBody>
       </p:sp>
@@ -2216,21 +2180,9 @@
           <a:bodyPr wrap="square" lIns="0" tIns="0" rIns="0" bIns="0" rtlCol="0" anchor="t"/>
           <a:lstStyle/>
           <a:p>
-            <a:pPr algn="l" indent="0" marL="0">
-              <a:buNone/>
-            </a:pPr>
-            <a:r>
-              <a:rPr lang="en-US" sz="1050" dirty="0">
-                <a:solidFill>
-                  <a:srgbClr val="5F7388"/>
-                </a:solidFill>
-                <a:latin typeface="Calibri" pitchFamily="34" charset="0"/>
-                <a:ea typeface="Calibri" pitchFamily="34" charset="-122"/>
-                <a:cs typeface="Calibri" pitchFamily="34" charset="-120"/>
-              </a:rPr>
-              <a:t>Live provincial indicators: GDP, employment, trade flows, and sector contributions from Statistics Canada.</a:t>
-            </a:r>
-            <a:endParaRPr lang="en-US" sz="1050" dirty="0"/>
+            <a:r>
+              <a:t>Current view of BC macro conditions, based on the best available and most reliable data.</a:t>
+            </a:r>
           </a:p>
         </p:txBody>
       </p:sp>
@@ -2351,21 +2303,9 @@
           <a:bodyPr wrap="square" lIns="0" tIns="0" rIns="0" bIns="0" rtlCol="0" anchor="t"/>
           <a:lstStyle/>
           <a:p>
-            <a:pPr algn="l" indent="0" marL="0">
-              <a:buNone/>
-            </a:pPr>
-            <a:r>
-              <a:rPr lang="en-US" sz="1200" b="1" dirty="0">
-                <a:solidFill>
-                  <a:srgbClr val="1C2A39"/>
-                </a:solidFill>
-                <a:latin typeface="Calibri" pitchFamily="34" charset="0"/>
-                <a:ea typeface="Calibri" pitchFamily="34" charset="-122"/>
-                <a:cs typeface="Calibri" pitchFamily="34" charset="-120"/>
-              </a:rPr>
-              <a:t>Look West Strategy</a:t>
-            </a:r>
-            <a:endParaRPr lang="en-US" sz="1200" dirty="0"/>
+            <a:r>
+              <a:t>BC Trade Analysis</a:t>
+            </a:r>
           </a:p>
         </p:txBody>
       </p:sp>
@@ -2390,21 +2330,9 @@
           <a:bodyPr wrap="square" lIns="0" tIns="0" rIns="0" bIns="0" rtlCol="0" anchor="t"/>
           <a:lstStyle/>
           <a:p>
-            <a:pPr algn="l" indent="0" marL="0">
-              <a:buNone/>
-            </a:pPr>
-            <a:r>
-              <a:rPr lang="en-US" sz="1050" dirty="0">
-                <a:solidFill>
-                  <a:srgbClr val="5F7388"/>
-                </a:solidFill>
-                <a:latin typeface="Calibri" pitchFamily="34" charset="0"/>
-                <a:ea typeface="Calibri" pitchFamily="34" charset="-122"/>
-                <a:cs typeface="Calibri" pitchFamily="34" charset="-120"/>
-              </a:rPr>
-              <a:t>End-to-end strategy tracker: media coverage, funding &amp; investments, policy &amp; regulations in one view.</a:t>
-            </a:r>
-            <a:endParaRPr lang="en-US" sz="1050" dirty="0"/>
+            <a:r>
+              <a:t>Trade composition and interprovincial/international trends to support market-focused analysis.</a:t>
+            </a:r>
           </a:p>
         </p:txBody>
       </p:sp>
@@ -2525,21 +2453,9 @@
           <a:bodyPr wrap="square" lIns="0" tIns="0" rIns="0" bIns="0" rtlCol="0" anchor="t"/>
           <a:lstStyle/>
           <a:p>
-            <a:pPr algn="l" indent="0" marL="0">
-              <a:buNone/>
-            </a:pPr>
-            <a:r>
-              <a:rPr lang="en-US" sz="1200" b="1" dirty="0">
-                <a:solidFill>
-                  <a:srgbClr val="1C2A39"/>
-                </a:solidFill>
-                <a:latin typeface="Calibri" pitchFamily="34" charset="0"/>
-                <a:ea typeface="Calibri" pitchFamily="34" charset="-122"/>
-                <a:cs typeface="Calibri" pitchFamily="34" charset="-120"/>
-              </a:rPr>
-              <a:t>Sector Intelligence</a:t>
-            </a:r>
-            <a:endParaRPr lang="en-US" sz="1200" dirty="0"/>
+            <a:r>
+              <a:t>Look West Strategy</a:t>
+            </a:r>
           </a:p>
         </p:txBody>
       </p:sp>
@@ -2564,21 +2480,9 @@
           <a:bodyPr wrap="square" lIns="0" tIns="0" rIns="0" bIns="0" rtlCol="0" anchor="t"/>
           <a:lstStyle/>
           <a:p>
-            <a:pPr algn="l" indent="0" marL="0">
-              <a:buNone/>
-            </a:pPr>
-            <a:r>
-              <a:rPr lang="en-US" sz="1050" dirty="0">
-                <a:solidFill>
-                  <a:srgbClr val="5F7388"/>
-                </a:solidFill>
-                <a:latin typeface="Calibri" pitchFamily="34" charset="0"/>
-                <a:ea typeface="Calibri" pitchFamily="34" charset="-122"/>
-                <a:cs typeface="Calibri" pitchFamily="34" charset="-120"/>
-              </a:rPr>
-              <a:t>9 dedicated sector dashboards covering Life Sciences, Aerospace, Maritime, AI, Tourism and more.</a:t>
-            </a:r>
-            <a:endParaRPr lang="en-US" sz="1050" dirty="0"/>
+            <a:r>
+              <a:t>Three key sections: Strategy Overview, 8 Sectors, and Major Projects (under development).</a:t>
+            </a:r>
           </a:p>
         </p:txBody>
       </p:sp>
@@ -2699,21 +2603,9 @@
           <a:bodyPr wrap="square" lIns="0" tIns="0" rIns="0" bIns="0" rtlCol="0" anchor="ctr"/>
           <a:lstStyle/>
           <a:p>
-            <a:pPr algn="l" indent="0" marL="0">
-              <a:buNone/>
-            </a:pPr>
-            <a:r>
-              <a:rPr lang="en-US" sz="3300" b="1" dirty="0">
-                <a:solidFill>
-                  <a:srgbClr val="1C2A39"/>
-                </a:solidFill>
-                <a:latin typeface="Calibri" pitchFamily="34" charset="0"/>
-                <a:ea typeface="Calibri" pitchFamily="34" charset="-122"/>
-                <a:cs typeface="Calibri" pitchFamily="34" charset="-120"/>
-              </a:rPr>
-              <a:t>BC Macroeconomy</a:t>
-            </a:r>
-            <a:endParaRPr lang="en-US" sz="3300" dirty="0"/>
+            <a:r>
+              <a:t>BC Economy Snapshot</a:t>
+            </a:r>
           </a:p>
         </p:txBody>
       </p:sp>
@@ -2738,21 +2630,9 @@
           <a:bodyPr wrap="square" lIns="0" tIns="0" rIns="0" bIns="0" rtlCol="0" anchor="t"/>
           <a:lstStyle/>
           <a:p>
-            <a:pPr algn="l" indent="0" marL="0">
-              <a:buNone/>
-            </a:pPr>
-            <a:r>
-              <a:rPr lang="en-US" sz="1150" dirty="0">
-                <a:solidFill>
-                  <a:srgbClr val="5F7388"/>
-                </a:solidFill>
-                <a:latin typeface="Calibri" pitchFamily="34" charset="0"/>
-                <a:ea typeface="Calibri" pitchFamily="34" charset="-122"/>
-                <a:cs typeface="Calibri" pitchFamily="34" charset="-120"/>
-              </a:rPr>
-              <a:t>A live view of British Columbia's economic health, auto-refreshed from Statistics Canada and primary sources.</a:t>
-            </a:r>
-            <a:endParaRPr lang="en-US" sz="1150" dirty="0"/>
+            <a:r>
+              <a:t>A focused view of British Columbia economic conditions, using indicators selected for data availability and reliability.</a:t>
+            </a:r>
           </a:p>
         </p:txBody>
       </p:sp>
@@ -2802,21 +2682,9 @@
           <a:bodyPr wrap="square" lIns="0" tIns="0" rIns="0" bIns="0" rtlCol="0" anchor="ctr"/>
           <a:lstStyle/>
           <a:p>
-            <a:pPr algn="l" indent="0" marL="0">
-              <a:buNone/>
-            </a:pPr>
-            <a:r>
-              <a:rPr lang="en-US" sz="1200" b="1" dirty="0">
-                <a:solidFill>
-                  <a:srgbClr val="1C2A39"/>
-                </a:solidFill>
-                <a:latin typeface="Calibri" pitchFamily="34" charset="0"/>
-                <a:ea typeface="Calibri" pitchFamily="34" charset="-122"/>
-                <a:cs typeface="Calibri" pitchFamily="34" charset="-120"/>
-              </a:rPr>
-              <a:t>GDP &amp; Growth</a:t>
-            </a:r>
-            <a:endParaRPr lang="en-US" sz="1200" dirty="0"/>
+            <a:r>
+              <a:t>Core Indicators</a:t>
+            </a:r>
           </a:p>
         </p:txBody>
       </p:sp>
@@ -2841,21 +2709,9 @@
           <a:bodyPr wrap="square" lIns="0" tIns="0" rIns="0" bIns="0" rtlCol="0" anchor="ctr"/>
           <a:lstStyle/>
           <a:p>
-            <a:pPr algn="l" indent="0" marL="0">
-              <a:buNone/>
-            </a:pPr>
-            <a:r>
-              <a:rPr lang="en-US" sz="1000" dirty="0">
-                <a:solidFill>
-                  <a:srgbClr val="5F7388"/>
-                </a:solidFill>
-                <a:latin typeface="Calibri" pitchFamily="34" charset="0"/>
-                <a:ea typeface="Calibri" pitchFamily="34" charset="-122"/>
-                <a:cs typeface="Calibri" pitchFamily="34" charset="-120"/>
-              </a:rPr>
-              <a:t>Provincial output and sector-level contributions</a:t>
-            </a:r>
-            <a:endParaRPr lang="en-US" sz="1000" dirty="0"/>
+            <a:r>
+              <a:t>GDP, employment, labour force, unemployment, inflation, and related sector signals.</a:t>
+            </a:r>
           </a:p>
         </p:txBody>
       </p:sp>
@@ -3008,21 +2864,9 @@
           <a:bodyPr wrap="square" lIns="0" tIns="0" rIns="0" bIns="0" rtlCol="0" anchor="ctr"/>
           <a:lstStyle/>
           <a:p>
-            <a:pPr algn="l" indent="0" marL="0">
-              <a:buNone/>
-            </a:pPr>
-            <a:r>
-              <a:rPr lang="en-US" sz="1200" b="1" dirty="0">
-                <a:solidFill>
-                  <a:srgbClr val="1C2A39"/>
-                </a:solidFill>
-                <a:latin typeface="Calibri" pitchFamily="34" charset="0"/>
-                <a:ea typeface="Calibri" pitchFamily="34" charset="-122"/>
-                <a:cs typeface="Calibri" pitchFamily="34" charset="-120"/>
-              </a:rPr>
-              <a:t>Trade Flows</a:t>
-            </a:r>
-            <a:endParaRPr lang="en-US" sz="1200" dirty="0"/>
+            <a:r>
+              <a:t>Trade &amp; Industry</a:t>
+            </a:r>
           </a:p>
         </p:txBody>
       </p:sp>
@@ -3047,21 +2891,9 @@
           <a:bodyPr wrap="square" lIns="0" tIns="0" rIns="0" bIns="0" rtlCol="0" anchor="ctr"/>
           <a:lstStyle/>
           <a:p>
-            <a:pPr algn="l" indent="0" marL="0">
-              <a:buNone/>
-            </a:pPr>
-            <a:r>
-              <a:rPr lang="en-US" sz="1000" dirty="0">
-                <a:solidFill>
-                  <a:srgbClr val="5F7388"/>
-                </a:solidFill>
-                <a:latin typeface="Calibri" pitchFamily="34" charset="0"/>
-                <a:ea typeface="Calibri" pitchFamily="34" charset="-122"/>
-                <a:cs typeface="Calibri" pitchFamily="34" charset="-120"/>
-              </a:rPr>
-              <a:t>Exports, imports, and Indo-Pacific market metrics</a:t>
-            </a:r>
-            <a:endParaRPr lang="en-US" sz="1000" dirty="0"/>
+            <a:r>
+              <a:t>Trade flows and industry-level context to support integrated economic assessment.</a:t>
+            </a:r>
           </a:p>
         </p:txBody>
       </p:sp>
@@ -3111,21 +2943,9 @@
           <a:bodyPr wrap="square" lIns="0" tIns="0" rIns="0" bIns="0" rtlCol="0" anchor="ctr"/>
           <a:lstStyle/>
           <a:p>
-            <a:pPr algn="l" indent="0" marL="0">
-              <a:buNone/>
-            </a:pPr>
-            <a:r>
-              <a:rPr lang="en-US" sz="1200" b="1" dirty="0">
-                <a:solidFill>
-                  <a:srgbClr val="1C2A39"/>
-                </a:solidFill>
-                <a:latin typeface="Calibri" pitchFamily="34" charset="0"/>
-                <a:ea typeface="Calibri" pitchFamily="34" charset="-122"/>
-                <a:cs typeface="Calibri" pitchFamily="34" charset="-120"/>
-              </a:rPr>
-              <a:t>Live Data Feed</a:t>
-            </a:r>
-            <a:endParaRPr lang="en-US" sz="1200" dirty="0"/>
+            <a:r>
+              <a:t>Data Confidence</a:t>
+            </a:r>
           </a:p>
         </p:txBody>
       </p:sp>
@@ -3150,21 +2970,9 @@
           <a:bodyPr wrap="square" lIns="0" tIns="0" rIns="0" bIns="0" rtlCol="0" anchor="ctr"/>
           <a:lstStyle/>
           <a:p>
-            <a:pPr algn="l" indent="0" marL="0">
-              <a:buNone/>
-            </a:pPr>
-            <a:r>
-              <a:rPr lang="en-US" sz="1000" dirty="0">
-                <a:solidFill>
-                  <a:srgbClr val="5F7388"/>
-                </a:solidFill>
-                <a:latin typeface="Calibri" pitchFamily="34" charset="0"/>
-                <a:ea typeface="Calibri" pitchFamily="34" charset="-122"/>
-                <a:cs typeface="Calibri" pitchFamily="34" charset="-120"/>
-              </a:rPr>
-              <a:t>One-click refresh from Statistics Canada APIs</a:t>
-            </a:r>
-            <a:endParaRPr lang="en-US" sz="1000" dirty="0"/>
+            <a:r>
+              <a:t>Indicators are prioritized based on availability, timeliness, and reliability.</a:t>
+            </a:r>
           </a:p>
         </p:txBody>
       </p:sp>
@@ -3246,21 +3054,9 @@
           <a:bodyPr wrap="square" lIns="0" tIns="0" rIns="0" bIns="0" rtlCol="0" anchor="ctr"/>
           <a:lstStyle/>
           <a:p>
-            <a:pPr algn="l" indent="0" marL="0">
-              <a:buNone/>
-            </a:pPr>
-            <a:r>
-              <a:rPr lang="en-US" sz="3400" b="1" dirty="0">
-                <a:solidFill>
-                  <a:srgbClr val="0B4F8A"/>
-                </a:solidFill>
-                <a:latin typeface="Calibri" pitchFamily="34" charset="0"/>
-                <a:ea typeface="Calibri" pitchFamily="34" charset="-122"/>
-                <a:cs typeface="Calibri" pitchFamily="34" charset="-120"/>
-              </a:rPr>
-              <a:t>Live</a:t>
-            </a:r>
-            <a:endParaRPr lang="en-US" sz="3400" dirty="0"/>
+            <a:r>
+              <a:t>Current</a:t>
+            </a:r>
           </a:p>
         </p:txBody>
       </p:sp>
@@ -3285,21 +3081,9 @@
           <a:bodyPr wrap="square" lIns="0" tIns="0" rIns="0" bIns="0" rtlCol="0" anchor="ctr"/>
           <a:lstStyle/>
           <a:p>
-            <a:pPr algn="l" indent="0" marL="0">
-              <a:buNone/>
-            </a:pPr>
-            <a:r>
-              <a:rPr lang="en-US" sz="1000" b="1" spc="50" kern="0" dirty="0">
-                <a:solidFill>
-                  <a:srgbClr val="1565A8"/>
-                </a:solidFill>
-                <a:latin typeface="Calibri" pitchFamily="34" charset="0"/>
-                <a:ea typeface="Calibri" pitchFamily="34" charset="-122"/>
-                <a:cs typeface="Calibri" pitchFamily="34" charset="-120"/>
-              </a:rPr>
-              <a:t>StatsCan Connection</a:t>
-            </a:r>
-            <a:endParaRPr lang="en-US" sz="1000" dirty="0"/>
+            <a:r>
+              <a:t>BC Signals</a:t>
+            </a:r>
           </a:p>
         </p:txBody>
       </p:sp>
@@ -3324,21 +3108,9 @@
           <a:bodyPr wrap="square" lIns="0" tIns="0" rIns="0" bIns="0" rtlCol="0" anchor="ctr"/>
           <a:lstStyle/>
           <a:p>
-            <a:pPr algn="l" indent="0" marL="0">
-              <a:buNone/>
-            </a:pPr>
-            <a:r>
-              <a:rPr lang="en-US" sz="950" dirty="0">
-                <a:solidFill>
-                  <a:srgbClr val="5F7388"/>
-                </a:solidFill>
-                <a:latin typeface="Calibri" pitchFamily="34" charset="0"/>
-                <a:ea typeface="Calibri" pitchFamily="34" charset="-122"/>
-                <a:cs typeface="Calibri" pitchFamily="34" charset="-120"/>
-              </a:rPr>
-              <a:t>Auto-refreshed economic indicators</a:t>
-            </a:r>
-            <a:endParaRPr lang="en-US" sz="950" dirty="0"/>
+            <a:r>
+              <a:t>Economy indicators in one standardized view</a:t>
+            </a:r>
           </a:p>
         </p:txBody>
       </p:sp>
@@ -3420,21 +3192,9 @@
           <a:bodyPr wrap="square" lIns="0" tIns="0" rIns="0" bIns="0" rtlCol="0" anchor="ctr"/>
           <a:lstStyle/>
           <a:p>
-            <a:pPr algn="l" indent="0" marL="0">
-              <a:buNone/>
-            </a:pPr>
-            <a:r>
-              <a:rPr lang="en-US" sz="3400" b="1" dirty="0">
-                <a:solidFill>
-                  <a:srgbClr val="0B4F8A"/>
-                </a:solidFill>
-                <a:latin typeface="Calibri" pitchFamily="34" charset="0"/>
-                <a:ea typeface="Calibri" pitchFamily="34" charset="-122"/>
-                <a:cs typeface="Calibri" pitchFamily="34" charset="-120"/>
-              </a:rPr>
-              <a:t>4</a:t>
-            </a:r>
-            <a:endParaRPr lang="en-US" sz="3400" dirty="0"/>
+            <a:r>
+              <a:t>API + LAN</a:t>
+            </a:r>
           </a:p>
         </p:txBody>
       </p:sp>
@@ -3459,21 +3219,9 @@
           <a:bodyPr wrap="square" lIns="0" tIns="0" rIns="0" bIns="0" rtlCol="0" anchor="ctr"/>
           <a:lstStyle/>
           <a:p>
-            <a:pPr algn="l" indent="0" marL="0">
-              <a:buNone/>
-            </a:pPr>
-            <a:r>
-              <a:rPr lang="en-US" sz="1000" b="1" spc="50" kern="0" dirty="0">
-                <a:solidFill>
-                  <a:srgbClr val="1565A8"/>
-                </a:solidFill>
-                <a:latin typeface="Calibri" pitchFamily="34" charset="0"/>
-                <a:ea typeface="Calibri" pitchFamily="34" charset="-122"/>
-                <a:cs typeface="Calibri" pitchFamily="34" charset="-120"/>
-              </a:rPr>
-              <a:t>Indicator Groups</a:t>
-            </a:r>
-            <a:endParaRPr lang="en-US" sz="1000" dirty="0"/>
+            <a:r>
+              <a:t>Data Sources</a:t>
+            </a:r>
           </a:p>
         </p:txBody>
       </p:sp>
@@ -3498,21 +3246,9 @@
           <a:bodyPr wrap="square" lIns="0" tIns="0" rIns="0" bIns="0" rtlCol="0" anchor="ctr"/>
           <a:lstStyle/>
           <a:p>
-            <a:pPr algn="l" indent="0" marL="0">
-              <a:buNone/>
-            </a:pPr>
-            <a:r>
-              <a:rPr lang="en-US" sz="950" dirty="0">
-                <a:solidFill>
-                  <a:srgbClr val="5F7388"/>
-                </a:solidFill>
-                <a:latin typeface="Calibri" pitchFamily="34" charset="0"/>
-                <a:ea typeface="Calibri" pitchFamily="34" charset="-122"/>
-                <a:cs typeface="Calibri" pitchFamily="34" charset="-120"/>
-              </a:rPr>
-              <a:t>GDP · Trade · Employment · Sector</a:t>
-            </a:r>
-            <a:endParaRPr lang="en-US" sz="950" dirty="0"/>
+            <a:r>
+              <a:t>Statistics Canada APIs and internal LAN-managed files</a:t>
+            </a:r>
           </a:p>
         </p:txBody>
       </p:sp>
@@ -3594,21 +3330,9 @@
           <a:bodyPr wrap="square" lIns="0" tIns="0" rIns="0" bIns="0" rtlCol="0" anchor="ctr"/>
           <a:lstStyle/>
           <a:p>
-            <a:pPr algn="l" indent="0" marL="0">
-              <a:buNone/>
-            </a:pPr>
-            <a:r>
-              <a:rPr lang="en-US" sz="3400" b="1" dirty="0">
-                <a:solidFill>
-                  <a:srgbClr val="0B4F8A"/>
-                </a:solidFill>
-                <a:latin typeface="Calibri" pitchFamily="34" charset="0"/>
-                <a:ea typeface="Calibri" pitchFamily="34" charset="-122"/>
-                <a:cs typeface="Calibri" pitchFamily="34" charset="-120"/>
-              </a:rPr>
-              <a:t>1-click</a:t>
-            </a:r>
-            <a:endParaRPr lang="en-US" sz="3400" dirty="0"/>
+            <a:r>
+              <a:t>Standardized</a:t>
+            </a:r>
           </a:p>
         </p:txBody>
       </p:sp>
@@ -3633,21 +3357,9 @@
           <a:bodyPr wrap="square" lIns="0" tIns="0" rIns="0" bIns="0" rtlCol="0" anchor="ctr"/>
           <a:lstStyle/>
           <a:p>
-            <a:pPr algn="l" indent="0" marL="0">
-              <a:buNone/>
-            </a:pPr>
-            <a:r>
-              <a:rPr lang="en-US" sz="1000" b="1" spc="50" kern="0" dirty="0">
-                <a:solidFill>
-                  <a:srgbClr val="1565A8"/>
-                </a:solidFill>
-                <a:latin typeface="Calibri" pitchFamily="34" charset="0"/>
-                <a:ea typeface="Calibri" pitchFamily="34" charset="-122"/>
-                <a:cs typeface="Calibri" pitchFamily="34" charset="-120"/>
-              </a:rPr>
-              <a:t>Data Refresh</a:t>
-            </a:r>
-            <a:endParaRPr lang="en-US" sz="1000" dirty="0"/>
+            <a:r>
+              <a:t>Communication</a:t>
+            </a:r>
           </a:p>
         </p:txBody>
       </p:sp>
@@ -3672,21 +3384,9 @@
           <a:bodyPr wrap="square" lIns="0" tIns="0" rIns="0" bIns="0" rtlCol="0" anchor="ctr"/>
           <a:lstStyle/>
           <a:p>
-            <a:pPr algn="l" indent="0" marL="0">
-              <a:buNone/>
-            </a:pPr>
-            <a:r>
-              <a:rPr lang="en-US" sz="950" dirty="0">
-                <a:solidFill>
-                  <a:srgbClr val="5F7388"/>
-                </a:solidFill>
-                <a:latin typeface="Calibri" pitchFamily="34" charset="0"/>
-                <a:ea typeface="Calibri" pitchFamily="34" charset="-122"/>
-                <a:cs typeface="Calibri" pitchFamily="34" charset="-120"/>
-              </a:rPr>
-              <a:t>"Update Data" refreshes all charts</a:t>
-            </a:r>
-            <a:endParaRPr lang="en-US" sz="950" dirty="0"/>
+            <a:r>
+              <a:t>Consistent KPI and chart structure for internal reporting</a:t>
+            </a:r>
           </a:p>
         </p:txBody>
       </p:sp>
@@ -3768,21 +3468,9 @@
           <a:bodyPr wrap="square" lIns="0" tIns="0" rIns="0" bIns="0" rtlCol="0" anchor="ctr"/>
           <a:lstStyle/>
           <a:p>
-            <a:pPr algn="l" indent="0" marL="0">
-              <a:buNone/>
-            </a:pPr>
-            <a:r>
-              <a:rPr lang="en-US" sz="750" b="1" spc="300" kern="0" dirty="0">
-                <a:solidFill>
-                  <a:srgbClr val="0B4F8A"/>
-                </a:solidFill>
-                <a:latin typeface="Calibri" pitchFamily="34" charset="0"/>
-                <a:ea typeface="Calibri" pitchFamily="34" charset="-122"/>
-                <a:cs typeface="Calibri" pitchFamily="34" charset="-120"/>
-              </a:rPr>
-              <a:t>DASHBOARD PAGE 2  —  FLAGSHIP TRACKER</a:t>
-            </a:r>
-            <a:endParaRPr lang="en-US" sz="750" dirty="0"/>
+            <a:r>
+              <a:t>LOOK WEST</a:t>
+            </a:r>
           </a:p>
         </p:txBody>
       </p:sp>
@@ -3807,21 +3495,9 @@
           <a:bodyPr wrap="square" lIns="0" tIns="0" rIns="0" bIns="0" rtlCol="0" anchor="ctr"/>
           <a:lstStyle/>
           <a:p>
-            <a:pPr algn="l" indent="0" marL="0">
-              <a:buNone/>
-            </a:pPr>
-            <a:r>
-              <a:rPr lang="en-US" sz="3300" b="1" dirty="0">
-                <a:solidFill>
-                  <a:srgbClr val="1C2A39"/>
-                </a:solidFill>
-                <a:latin typeface="Calibri" pitchFamily="34" charset="0"/>
-                <a:ea typeface="Calibri" pitchFamily="34" charset="-122"/>
-                <a:cs typeface="Calibri" pitchFamily="34" charset="-120"/>
-              </a:rPr>
+            <a:r>
               <a:t>Look West Strategy</a:t>
             </a:r>
-            <a:endParaRPr lang="en-US" sz="3300" dirty="0"/>
           </a:p>
         </p:txBody>
       </p:sp>
@@ -3846,21 +3522,9 @@
           <a:bodyPr wrap="square" lIns="0" tIns="0" rIns="0" bIns="0" rtlCol="0" anchor="t"/>
           <a:lstStyle/>
           <a:p>
-            <a:pPr algn="l" indent="0" marL="0">
-              <a:buNone/>
-            </a:pPr>
-            <a:r>
-              <a:rPr lang="en-US" sz="1150" dirty="0">
-                <a:solidFill>
-                  <a:srgbClr val="5F7388"/>
-                </a:solidFill>
-                <a:latin typeface="Calibri" pitchFamily="34" charset="0"/>
-                <a:ea typeface="Calibri" pitchFamily="34" charset="-122"/>
-                <a:cs typeface="Calibri" pitchFamily="34" charset="-120"/>
-              </a:rPr>
-              <a:t>End-to-end visibility into BC's strategic trade and economic agenda — three live data streams, one unified view, organized across 4 Look West Pillars.</a:t>
-            </a:r>
-            <a:endParaRPr lang="en-US" sz="1150" dirty="0"/>
+            <a:r>
+              <a:t>Organized into 3 key sections for internal monitoring and communication of progress.</a:t>
+            </a:r>
           </a:p>
         </p:txBody>
       </p:sp>
@@ -3942,21 +3606,9 @@
           <a:bodyPr wrap="square" lIns="0" tIns="0" rIns="0" bIns="0" rtlCol="0" anchor="t"/>
           <a:lstStyle/>
           <a:p>
-            <a:pPr algn="l" indent="0" marL="0">
-              <a:buNone/>
-            </a:pPr>
-            <a:r>
-              <a:rPr lang="en-US" sz="1250" b="1" dirty="0">
-                <a:solidFill>
-                  <a:srgbClr val="1C2A39"/>
-                </a:solidFill>
-                <a:latin typeface="Calibri" pitchFamily="34" charset="0"/>
-                <a:ea typeface="Calibri" pitchFamily="34" charset="-122"/>
-                <a:cs typeface="Calibri" pitchFamily="34" charset="-120"/>
-              </a:rPr>
-              <a:t>Media Coverage Tracker</a:t>
-            </a:r>
-            <a:endParaRPr lang="en-US" sz="1250" dirty="0"/>
+            <a:r>
+              <a:t>1. Strategy Overview</a:t>
+            </a:r>
           </a:p>
         </p:txBody>
       </p:sp>
@@ -3981,21 +3633,9 @@
           <a:bodyPr wrap="square" lIns="0" tIns="0" rIns="0" bIns="0" rtlCol="0" anchor="t"/>
           <a:lstStyle/>
           <a:p>
-            <a:pPr algn="l" indent="0" marL="0">
-              <a:buNone/>
-            </a:pPr>
-            <a:r>
-              <a:rPr lang="en-US" sz="1050" dirty="0">
-                <a:solidFill>
-                  <a:srgbClr val="5F7388"/>
-                </a:solidFill>
-                <a:latin typeface="Calibri" pitchFamily="34" charset="0"/>
-                <a:ea typeface="Calibri" pitchFamily="34" charset="-122"/>
-                <a:cs typeface="Calibri" pitchFamily="34" charset="-120"/>
-              </a:rPr>
-              <a:t>Tracks BC government and media mentions across multiple news sources. Categorized by Look West pillar, theme, and source type.</a:t>
-            </a:r>
-            <a:endParaRPr lang="en-US" sz="1050" dirty="0"/>
+            <a:r>
+              <a:t>High-level monitoring of strategic progress, signals, and overall direction.</a:t>
+            </a:r>
           </a:p>
         </p:txBody>
       </p:sp>
@@ -4047,21 +3687,9 @@
           <a:bodyPr wrap="square" lIns="0" tIns="0" rIns="0" bIns="0" rtlCol="0" anchor="ctr"/>
           <a:lstStyle/>
           <a:p>
-            <a:pPr algn="ctr" indent="0" marL="0">
-              <a:buNone/>
-            </a:pPr>
-            <a:r>
-              <a:rPr lang="en-US" sz="850" b="1" dirty="0">
-                <a:solidFill>
-                  <a:srgbClr val="0B4F8A"/>
-                </a:solidFill>
-                <a:latin typeface="Calibri" pitchFamily="34" charset="0"/>
-                <a:ea typeface="Calibri" pitchFamily="34" charset="-122"/>
-                <a:cs typeface="Calibri" pitchFamily="34" charset="-120"/>
-              </a:rPr>
-              <a:t>BC Gov · Federal · Industry · Other</a:t>
-            </a:r>
-            <a:endParaRPr lang="en-US" sz="850" dirty="0"/>
+            <a:r>
+              <a:t>Progress summary · Key signals</a:t>
+            </a:r>
           </a:p>
         </p:txBody>
       </p:sp>
@@ -4143,21 +3771,9 @@
           <a:bodyPr wrap="square" lIns="0" tIns="0" rIns="0" bIns="0" rtlCol="0" anchor="t"/>
           <a:lstStyle/>
           <a:p>
-            <a:pPr algn="l" indent="0" marL="0">
-              <a:buNone/>
-            </a:pPr>
-            <a:r>
-              <a:rPr lang="en-US" sz="1250" b="1" dirty="0">
-                <a:solidFill>
-                  <a:srgbClr val="1C2A39"/>
-                </a:solidFill>
-                <a:latin typeface="Calibri" pitchFamily="34" charset="0"/>
-                <a:ea typeface="Calibri" pitchFamily="34" charset="-122"/>
-                <a:cs typeface="Calibri" pitchFamily="34" charset="-120"/>
-              </a:rPr>
-              <a:t>Funding &amp; Investments</a:t>
-            </a:r>
-            <a:endParaRPr lang="en-US" sz="1250" dirty="0"/>
+            <a:r>
+              <a:t>2. Sectors (8)</a:t>
+            </a:r>
           </a:p>
         </p:txBody>
       </p:sp>
@@ -4182,21 +3798,9 @@
           <a:bodyPr wrap="square" lIns="0" tIns="0" rIns="0" bIns="0" rtlCol="0" anchor="t"/>
           <a:lstStyle/>
           <a:p>
-            <a:pPr algn="l" indent="0" marL="0">
-              <a:buNone/>
-            </a:pPr>
-            <a:r>
-              <a:rPr lang="en-US" sz="1050" dirty="0">
-                <a:solidFill>
-                  <a:srgbClr val="5F7388"/>
-                </a:solidFill>
-                <a:latin typeface="Calibri" pitchFamily="34" charset="0"/>
-                <a:ea typeface="Calibri" pitchFamily="34" charset="-122"/>
-                <a:cs typeface="Calibri" pitchFamily="34" charset="-120"/>
-              </a:rPr>
-              <a:t>Records every funding announcement with breakdowns by provincial commitment, investment attracted to BC, federal, and other sources.</a:t>
-            </a:r>
-            <a:endParaRPr lang="en-US" sz="1050" dirty="0"/>
+            <a:r>
+              <a:t>Eight sector dashboards with consistent structure and sector-specific data files.</a:t>
+            </a:r>
           </a:p>
         </p:txBody>
       </p:sp>
@@ -4248,21 +3852,9 @@
           <a:bodyPr wrap="square" lIns="0" tIns="0" rIns="0" bIns="0" rtlCol="0" anchor="ctr"/>
           <a:lstStyle/>
           <a:p>
-            <a:pPr algn="ctr" indent="0" marL="0">
-              <a:buNone/>
-            </a:pPr>
-            <a:r>
-              <a:rPr lang="en-US" sz="850" b="1" dirty="0">
-                <a:solidFill>
-                  <a:srgbClr val="1F7A4D"/>
-                </a:solidFill>
-                <a:latin typeface="Calibri" pitchFamily="34" charset="0"/>
-                <a:ea typeface="Calibri" pitchFamily="34" charset="-122"/>
-                <a:cs typeface="Calibri" pitchFamily="34" charset="-120"/>
-              </a:rPr>
-              <a:t>$M totals · Jobs created · By region</a:t>
-            </a:r>
-            <a:endParaRPr lang="en-US" sz="850" dirty="0"/>
+            <a:r>
+              <a:t>Life Sciences · Aerospace · Agriculture · AI &amp; Quantum · Construction · Maritime · Tourism · Trade &amp; Logistics</a:t>
+            </a:r>
           </a:p>
         </p:txBody>
       </p:sp>
@@ -4344,21 +3936,9 @@
           <a:bodyPr wrap="square" lIns="0" tIns="0" rIns="0" bIns="0" rtlCol="0" anchor="t"/>
           <a:lstStyle/>
           <a:p>
-            <a:pPr algn="l" indent="0" marL="0">
-              <a:buNone/>
-            </a:pPr>
-            <a:r>
-              <a:rPr lang="en-US" sz="1250" b="1" dirty="0">
-                <a:solidFill>
-                  <a:srgbClr val="1C2A39"/>
-                </a:solidFill>
-                <a:latin typeface="Calibri" pitchFamily="34" charset="0"/>
-                <a:ea typeface="Calibri" pitchFamily="34" charset="-122"/>
-                <a:cs typeface="Calibri" pitchFamily="34" charset="-120"/>
-              </a:rPr>
-              <a:t>Policy &amp; Regulations</a:t>
-            </a:r>
-            <a:endParaRPr lang="en-US" sz="1250" dirty="0"/>
+            <a:r>
+              <a:t>3. Major Projects</a:t>
+            </a:r>
           </a:p>
         </p:txBody>
       </p:sp>
@@ -4383,21 +3963,9 @@
           <a:bodyPr wrap="square" lIns="0" tIns="0" rIns="0" bIns="0" rtlCol="0" anchor="t"/>
           <a:lstStyle/>
           <a:p>
-            <a:pPr algn="l" indent="0" marL="0">
-              <a:buNone/>
-            </a:pPr>
-            <a:r>
-              <a:rPr lang="en-US" sz="1050" dirty="0">
-                <a:solidFill>
-                  <a:srgbClr val="5F7388"/>
-                </a:solidFill>
-                <a:latin typeface="Calibri" pitchFamily="34" charset="0"/>
-                <a:ea typeface="Calibri" pitchFamily="34" charset="-122"/>
-                <a:cs typeface="Calibri" pitchFamily="34" charset="-120"/>
-              </a:rPr>
-              <a:t>Monitors regulatory and policy changes by jurisdiction and Look West sector, mapped to LW Outcome Areas with source links.</a:t>
-            </a:r>
-            <a:endParaRPr lang="en-US" sz="1050" dirty="0"/>
+            <a:r>
+              <a:t>Major projects section is under development and planned for integration in this dashboard.</a:t>
+            </a:r>
           </a:p>
         </p:txBody>
       </p:sp>
@@ -4449,21 +4017,9 @@
           <a:bodyPr wrap="square" lIns="0" tIns="0" rIns="0" bIns="0" rtlCol="0" anchor="ctr"/>
           <a:lstStyle/>
           <a:p>
-            <a:pPr algn="ctr" indent="0" marL="0">
-              <a:buNone/>
-            </a:pPr>
-            <a:r>
-              <a:rPr lang="en-US" sz="850" b="1" dirty="0">
-                <a:solidFill>
-                  <a:srgbClr val="1565A8"/>
-                </a:solidFill>
-                <a:latin typeface="Calibri" pitchFamily="34" charset="0"/>
-                <a:ea typeface="Calibri" pitchFamily="34" charset="-122"/>
-                <a:cs typeface="Calibri" pitchFamily="34" charset="-120"/>
-              </a:rPr>
-              <a:t>By jurisdiction · By policy type</a:t>
-            </a:r>
-            <a:endParaRPr lang="en-US" sz="850" dirty="0"/>
+            <a:r>
+              <a:t>Status: Under development</a:t>
+            </a:r>
           </a:p>
         </p:txBody>
       </p:sp>
@@ -4488,21 +4044,9 @@
           <a:bodyPr wrap="square" lIns="0" tIns="0" rIns="0" bIns="0" rtlCol="0" anchor="ctr"/>
           <a:lstStyle/>
           <a:p>
-            <a:pPr algn="l" indent="0" marL="0">
-              <a:buNone/>
-            </a:pPr>
-            <a:r>
-              <a:rPr lang="en-US" sz="950" i="1" dirty="0">
-                <a:solidFill>
-                  <a:srgbClr val="5F7388"/>
-                </a:solidFill>
-                <a:latin typeface="Calibri" pitchFamily="34" charset="0"/>
-                <a:ea typeface="Calibri" pitchFamily="34" charset="-122"/>
-                <a:cs typeface="Calibri" pitchFamily="34" charset="-120"/>
-              </a:rPr>
-              <a:t>Filterable by pillar · theme · region · funding source  ·  Includes aggregate investment charts with show/hide toggle</a:t>
-            </a:r>
-            <a:endParaRPr lang="en-US" sz="950" dirty="0"/>
+            <a:r>
+              <a:t>Designed to align project monitoring with the same Look West framework.</a:t>
+            </a:r>
           </a:p>
         </p:txBody>
       </p:sp>
@@ -4584,21 +4128,9 @@
           <a:bodyPr wrap="square" lIns="0" tIns="0" rIns="0" bIns="0" rtlCol="0" anchor="ctr"/>
           <a:lstStyle/>
           <a:p>
-            <a:pPr algn="l" indent="0" marL="0">
-              <a:buNone/>
-            </a:pPr>
-            <a:r>
-              <a:rPr lang="en-US" sz="750" b="1" spc="300" kern="0" dirty="0">
-                <a:solidFill>
-                  <a:srgbClr val="0B4F8A"/>
-                </a:solidFill>
-                <a:latin typeface="Calibri" pitchFamily="34" charset="0"/>
-                <a:ea typeface="Calibri" pitchFamily="34" charset="-122"/>
-                <a:cs typeface="Calibri" pitchFamily="34" charset="-120"/>
-              </a:rPr>
-              <a:t>DASHBOARD PAGES 3 – 11</a:t>
-            </a:r>
-            <a:endParaRPr lang="en-US" sz="750" dirty="0"/>
+            <a:r>
+              <a:t>DASHBOARD PAGES 3 – 10</a:t>
+            </a:r>
           </a:p>
         </p:txBody>
       </p:sp>
@@ -4623,21 +4155,9 @@
           <a:bodyPr wrap="square" lIns="0" tIns="0" rIns="0" bIns="0" rtlCol="0" anchor="ctr"/>
           <a:lstStyle/>
           <a:p>
-            <a:pPr algn="l" indent="0" marL="0">
-              <a:buNone/>
-            </a:pPr>
-            <a:r>
-              <a:rPr lang="en-US" sz="3300" b="1" dirty="0">
-                <a:solidFill>
-                  <a:srgbClr val="1C2A39"/>
-                </a:solidFill>
-                <a:latin typeface="Calibri" pitchFamily="34" charset="0"/>
-                <a:ea typeface="Calibri" pitchFamily="34" charset="-122"/>
-                <a:cs typeface="Calibri" pitchFamily="34" charset="-120"/>
-              </a:rPr>
-              <a:t>Sector Intelligence</a:t>
-            </a:r>
-            <a:endParaRPr lang="en-US" sz="3300" dirty="0"/>
+            <a:r>
+              <a:t>Sectors</a:t>
+            </a:r>
           </a:p>
         </p:txBody>
       </p:sp>
@@ -4662,21 +4182,9 @@
           <a:bodyPr wrap="square" lIns="0" tIns="0" rIns="0" bIns="0" rtlCol="0" anchor="ctr"/>
           <a:lstStyle/>
           <a:p>
-            <a:pPr algn="l" indent="0" marL="0">
-              <a:buNone/>
-            </a:pPr>
-            <a:r>
-              <a:rPr lang="en-US" sz="7200" b="1" dirty="0">
-                <a:solidFill>
-                  <a:srgbClr val="0B4F8A"/>
-                </a:solidFill>
-                <a:latin typeface="Calibri" pitchFamily="34" charset="0"/>
-                <a:ea typeface="Calibri" pitchFamily="34" charset="-122"/>
-                <a:cs typeface="Calibri" pitchFamily="34" charset="-120"/>
-              </a:rPr>
-              <a:t>9</a:t>
-            </a:r>
-            <a:endParaRPr lang="en-US" sz="7200" dirty="0"/>
+            <a:r>
+              <a:t>8</a:t>
+            </a:r>
           </a:p>
         </p:txBody>
       </p:sp>
@@ -4701,21 +4209,9 @@
           <a:bodyPr wrap="square" lIns="0" tIns="0" rIns="0" bIns="0" rtlCol="0" anchor="t"/>
           <a:lstStyle/>
           <a:p>
-            <a:pPr algn="l" indent="0" marL="0">
-              <a:buNone/>
-            </a:pPr>
-            <a:r>
-              <a:rPr lang="en-US" sz="1350" b="1" dirty="0">
-                <a:solidFill>
-                  <a:srgbClr val="1C2A39"/>
-                </a:solidFill>
-                <a:latin typeface="Calibri" pitchFamily="34" charset="0"/>
-                <a:ea typeface="Calibri" pitchFamily="34" charset="-122"/>
-                <a:cs typeface="Calibri" pitchFamily="34" charset="-120"/>
-              </a:rPr>
+            <a:r>
               <a:t>Sector Dashboards</a:t>
             </a:r>
-            <a:endParaRPr lang="en-US" sz="1350" dirty="0"/>
           </a:p>
         </p:txBody>
       </p:sp>
@@ -4740,38 +4236,9 @@
           <a:bodyPr wrap="square" lIns="0" tIns="0" rIns="0" bIns="0" rtlCol="0" anchor="t"/>
           <a:lstStyle/>
           <a:p>
-            <a:pPr algn="l" indent="0" marL="0">
-              <a:buNone/>
-            </a:pPr>
-            <a:r>
-              <a:rPr lang="en-US" sz="1050" dirty="0">
-                <a:solidFill>
-                  <a:srgbClr val="5F7388"/>
-                </a:solidFill>
-                <a:latin typeface="Calibri" pitchFamily="34" charset="0"/>
-                <a:ea typeface="Calibri" pitchFamily="34" charset="-122"/>
-                <a:cs typeface="Calibri" pitchFamily="34" charset="-120"/>
-              </a:rPr>
-              <a:t>Each sector has its own dedicated</a:t>
-            </a:r>
-            <a:endParaRPr lang="en-US" sz="1050" dirty="0"/>
-          </a:p>
-          <a:p>
-            <a:pPr algn="l" indent="0" marL="0">
-              <a:buNone/>
-            </a:pPr>
-            <a:r>
-              <a:rPr lang="en-US" sz="1050" dirty="0">
-                <a:solidFill>
-                  <a:srgbClr val="5F7388"/>
-                </a:solidFill>
-                <a:latin typeface="Calibri" pitchFamily="34" charset="0"/>
-                <a:ea typeface="Calibri" pitchFamily="34" charset="-122"/>
-                <a:cs typeface="Calibri" pitchFamily="34" charset="-120"/>
-              </a:rPr>
-              <a:t>dashboard with a consistent structure.</a:t>
-            </a:r>
-            <a:endParaRPr lang="en-US" sz="1050" dirty="0"/>
+            <a:r>
+              <a:t>Each sector has its own dashboard and sector-specific Excel data file.</a:t>
+            </a:r>
           </a:p>
         </p:txBody>
       </p:sp>
@@ -4821,21 +4288,9 @@
           <a:bodyPr wrap="square" lIns="0" tIns="0" rIns="0" bIns="0" rtlCol="0" anchor="ctr"/>
           <a:lstStyle/>
           <a:p>
-            <a:pPr algn="l" indent="0" marL="0">
-              <a:buNone/>
-            </a:pPr>
-            <a:r>
-              <a:rPr lang="en-US" sz="1100" dirty="0">
-                <a:solidFill>
-                  <a:srgbClr val="1C2A39"/>
-                </a:solidFill>
-                <a:latin typeface="Calibri" pitchFamily="34" charset="0"/>
-                <a:ea typeface="Calibri" pitchFamily="34" charset="-122"/>
-                <a:cs typeface="Calibri" pitchFamily="34" charset="-120"/>
-              </a:rPr>
-              <a:t>KPI Cards — key sector metrics</a:t>
-            </a:r>
-            <a:endParaRPr lang="en-US" sz="1100" dirty="0"/>
+            <a:r>
+              <a:t>Standard structure across sectors</a:t>
+            </a:r>
           </a:p>
         </p:txBody>
       </p:sp>
@@ -4885,21 +4340,9 @@
           <a:bodyPr wrap="square" lIns="0" tIns="0" rIns="0" bIns="0" rtlCol="0" anchor="ctr"/>
           <a:lstStyle/>
           <a:p>
-            <a:pPr algn="l" indent="0" marL="0">
-              <a:buNone/>
-            </a:pPr>
-            <a:r>
-              <a:rPr lang="en-US" sz="1100" dirty="0">
-                <a:solidFill>
-                  <a:srgbClr val="1C2A39"/>
-                </a:solidFill>
-                <a:latin typeface="Calibri" pitchFamily="34" charset="0"/>
-                <a:ea typeface="Calibri" pitchFamily="34" charset="-122"/>
-                <a:cs typeface="Calibri" pitchFamily="34" charset="-120"/>
-              </a:rPr>
-              <a:t>Funding &amp; investment charts</a:t>
-            </a:r>
-            <a:endParaRPr lang="en-US" sz="1100" dirty="0"/>
+            <a:r>
+              <a:t>KPI cards and sector trends</a:t>
+            </a:r>
           </a:p>
         </p:txBody>
       </p:sp>
@@ -4949,21 +4392,9 @@
           <a:bodyPr wrap="square" lIns="0" tIns="0" rIns="0" bIns="0" rtlCol="0" anchor="ctr"/>
           <a:lstStyle/>
           <a:p>
-            <a:pPr algn="l" indent="0" marL="0">
-              <a:buNone/>
-            </a:pPr>
-            <a:r>
-              <a:rPr lang="en-US" sz="1100" dirty="0">
-                <a:solidFill>
-                  <a:srgbClr val="1C2A39"/>
-                </a:solidFill>
-                <a:latin typeface="Calibri" pitchFamily="34" charset="0"/>
-                <a:ea typeface="Calibri" pitchFamily="34" charset="-122"/>
-                <a:cs typeface="Calibri" pitchFamily="34" charset="-120"/>
-              </a:rPr>
-              <a:t>Initiative tracker with RAG status</a:t>
-            </a:r>
-            <a:endParaRPr lang="en-US" sz="1100" dirty="0"/>
+            <a:r>
+              <a:t>Initiatives, evidence, and risks</a:t>
+            </a:r>
           </a:p>
         </p:txBody>
       </p:sp>
@@ -5013,21 +4444,9 @@
           <a:bodyPr wrap="square" lIns="0" tIns="0" rIns="0" bIns="0" rtlCol="0" anchor="ctr"/>
           <a:lstStyle/>
           <a:p>
-            <a:pPr algn="l" indent="0" marL="0">
-              <a:buNone/>
-            </a:pPr>
-            <a:r>
-              <a:rPr lang="en-US" sz="1100" dirty="0">
-                <a:solidFill>
-                  <a:srgbClr val="1C2A39"/>
-                </a:solidFill>
-                <a:latin typeface="Calibri" pitchFamily="34" charset="0"/>
-                <a:ea typeface="Calibri" pitchFamily="34" charset="-122"/>
-                <a:cs typeface="Calibri" pitchFamily="34" charset="-120"/>
-              </a:rPr>
-              <a:t>Evidence and risk register</a:t>
-            </a:r>
-            <a:endParaRPr lang="en-US" sz="1100" dirty="0"/>
+            <a:r>
+              <a:t>Data maintained in sector Excel files</a:t>
+            </a:r>
           </a:p>
         </p:txBody>
       </p:sp>
@@ -5077,21 +4496,9 @@
           <a:bodyPr wrap="square" lIns="0" tIns="0" rIns="0" bIns="0" rtlCol="0" anchor="ctr"/>
           <a:lstStyle/>
           <a:p>
-            <a:pPr algn="l" indent="0" marL="0">
-              <a:buNone/>
-            </a:pPr>
-            <a:r>
-              <a:rPr lang="en-US" sz="1100" dirty="0">
-                <a:solidFill>
-                  <a:srgbClr val="1C2A39"/>
-                </a:solidFill>
-                <a:latin typeface="Calibri" pitchFamily="34" charset="0"/>
-                <a:ea typeface="Calibri" pitchFamily="34" charset="-122"/>
-                <a:cs typeface="Calibri" pitchFamily="34" charset="-120"/>
-              </a:rPr>
-              <a:t>Look West goal progress tracker</a:t>
-            </a:r>
-            <a:endParaRPr lang="en-US" sz="1100" dirty="0"/>
+            <a:r>
+              <a:t>Integrated into BC Insights Dashboard</a:t>
+            </a:r>
           </a:p>
         </p:txBody>
       </p:sp>
@@ -5908,23 +5315,7 @@
         <p:txBody>
           <a:bodyPr wrap="square" lIns="0" tIns="0" rIns="0" bIns="0" rtlCol="0" anchor="ctr"/>
           <a:lstStyle/>
-          <a:p>
-            <a:pPr algn="ctr" indent="0" marL="0">
-              <a:buNone/>
-            </a:pPr>
-            <a:r>
-              <a:rPr lang="en-US" sz="1000" i="1" dirty="0">
-                <a:solidFill>
-                  <a:srgbClr val="5F7388"/>
-                </a:solidFill>
-                <a:latin typeface="Calibri" pitchFamily="34" charset="0"/>
-                <a:ea typeface="Calibri" pitchFamily="34" charset="-122"/>
-                <a:cs typeface="Calibri" pitchFamily="34" charset="-120"/>
-              </a:rPr>
-              <a:t>+ 1 Future Sector  (placeholder ready)</a:t>
-            </a:r>
-            <a:endParaRPr lang="en-US" sz="1000" dirty="0"/>
-          </a:p>
+          <a:p/>
         </p:txBody>
       </p:sp>
     </p:spTree>
@@ -6005,21 +5396,9 @@
           <a:bodyPr wrap="square" lIns="0" tIns="0" rIns="0" bIns="0" rtlCol="0" anchor="ctr"/>
           <a:lstStyle/>
           <a:p>
-            <a:pPr algn="l" indent="0" marL="0">
-              <a:buNone/>
-            </a:pPr>
-            <a:r>
-              <a:rPr lang="en-US" sz="750" b="1" spc="300" kern="0" dirty="0">
-                <a:solidFill>
-                  <a:srgbClr val="0B4F8A"/>
-                </a:solidFill>
-                <a:latin typeface="Calibri" pitchFamily="34" charset="0"/>
-                <a:ea typeface="Calibri" pitchFamily="34" charset="-122"/>
-                <a:cs typeface="Calibri" pitchFamily="34" charset="-120"/>
-              </a:rPr>
-              <a:t>UNDER THE HOOD</a:t>
-            </a:r>
-            <a:endParaRPr lang="en-US" sz="750" dirty="0"/>
+            <a:r>
+              <a:t>DATA ARCHITECTURE</a:t>
+            </a:r>
           </a:p>
         </p:txBody>
       </p:sp>
@@ -6044,21 +5423,9 @@
           <a:bodyPr wrap="square" lIns="0" tIns="0" rIns="0" bIns="0" rtlCol="0" anchor="ctr"/>
           <a:lstStyle/>
           <a:p>
-            <a:pPr algn="l" indent="0" marL="0">
-              <a:buNone/>
-            </a:pPr>
-            <a:r>
-              <a:rPr lang="en-US" sz="3300" b="1" dirty="0">
-                <a:solidFill>
-                  <a:srgbClr val="1C2A39"/>
-                </a:solidFill>
-                <a:latin typeface="Calibri" pitchFamily="34" charset="0"/>
-                <a:ea typeface="Calibri" pitchFamily="34" charset="-122"/>
-                <a:cs typeface="Calibri" pitchFamily="34" charset="-120"/>
-              </a:rPr>
-              <a:t>Lightweight. Portable. Maintainable.</a:t>
-            </a:r>
-            <a:endParaRPr lang="en-US" sz="3300" dirty="0"/>
+            <a:r>
+              <a:t>No data is stored in the dashboard itself.</a:t>
+            </a:r>
           </a:p>
         </p:txBody>
       </p:sp>
@@ -6083,21 +5450,9 @@
           <a:bodyPr wrap="square" lIns="0" tIns="0" rIns="0" bIns="0" rtlCol="0" anchor="t"/>
           <a:lstStyle/>
           <a:p>
-            <a:pPr algn="l" indent="0" marL="0">
-              <a:buNone/>
-            </a:pPr>
-            <a:r>
-              <a:rPr lang="en-US" sz="1150" dirty="0">
-                <a:solidFill>
-                  <a:srgbClr val="5F7388"/>
-                </a:solidFill>
-                <a:latin typeface="Calibri" pitchFamily="34" charset="0"/>
-                <a:ea typeface="Calibri" pitchFamily="34" charset="-122"/>
-                <a:cs typeface="Calibri" pitchFamily="34" charset="-120"/>
-              </a:rPr>
-              <a:t>No cloud infrastructure. No external servers. Runs on any Windows laptop — ready for distribution today.</a:t>
-            </a:r>
-            <a:endParaRPr lang="en-US" sz="1150" dirty="0"/>
+            <a:r>
+              <a:t>Data is either pulled online through APIs or read from files in the standard internal LAN system.</a:t>
+            </a:r>
           </a:p>
         </p:txBody>
       </p:sp>
@@ -6218,21 +5573,9 @@
           <a:bodyPr wrap="square" lIns="0" tIns="0" rIns="0" bIns="0" rtlCol="0" anchor="t"/>
           <a:lstStyle/>
           <a:p>
-            <a:pPr algn="l" indent="0" marL="0">
-              <a:buNone/>
-            </a:pPr>
-            <a:r>
-              <a:rPr lang="en-US" sz="1300" b="1" dirty="0">
-                <a:solidFill>
-                  <a:srgbClr val="0B4F8A"/>
-                </a:solidFill>
-                <a:latin typeface="Calibri" pitchFamily="34" charset="0"/>
-                <a:ea typeface="Calibri" pitchFamily="34" charset="-122"/>
-                <a:cs typeface="Calibri" pitchFamily="34" charset="-120"/>
-              </a:rPr>
-              <a:t>Excel Data Files</a:t>
-            </a:r>
-            <a:endParaRPr lang="en-US" sz="1300" dirty="0"/>
+            <a:r>
+              <a:t>Online Data (APIs)</a:t>
+            </a:r>
           </a:p>
         </p:txBody>
       </p:sp>
@@ -6257,21 +5600,9 @@
           <a:bodyPr wrap="square" lIns="0" tIns="0" rIns="0" bIns="0" rtlCol="0" anchor="t"/>
           <a:lstStyle/>
           <a:p>
-            <a:pPr algn="l" indent="0" marL="0">
-              <a:buNone/>
-            </a:pPr>
-            <a:r>
-              <a:rPr lang="en-US" sz="1050" dirty="0">
-                <a:solidFill>
-                  <a:srgbClr val="5F7388"/>
-                </a:solidFill>
-                <a:latin typeface="Calibri" pitchFamily="34" charset="0"/>
-                <a:ea typeface="Calibri" pitchFamily="34" charset="-122"/>
-                <a:cs typeface="Calibri" pitchFamily="34" charset="-120"/>
-              </a:rPr>
-              <a:t>All data lives in .xlsx workbooks. Familiar, maintainable, and editable by any analyst — no technical skills required.</a:t>
-            </a:r>
-            <a:endParaRPr lang="en-US" sz="1050" dirty="0"/>
+            <a:r>
+              <a:t>Where reliable and available, indicators are loaded directly through APIs (e.g., Statistics Canada).</a:t>
+            </a:r>
           </a:p>
         </p:txBody>
       </p:sp>
@@ -6431,21 +5762,9 @@
           <a:bodyPr wrap="square" lIns="0" tIns="0" rIns="0" bIns="0" rtlCol="0" anchor="t"/>
           <a:lstStyle/>
           <a:p>
-            <a:pPr algn="l" indent="0" marL="0">
-              <a:buNone/>
-            </a:pPr>
-            <a:r>
-              <a:rPr lang="en-US" sz="1300" b="1" dirty="0">
-                <a:solidFill>
-                  <a:srgbClr val="1565A8"/>
-                </a:solidFill>
-                <a:latin typeface="Calibri" pitchFamily="34" charset="0"/>
-                <a:ea typeface="Calibri" pitchFamily="34" charset="-122"/>
-                <a:cs typeface="Calibri" pitchFamily="34" charset="-120"/>
-              </a:rPr>
-              <a:t>Local Python Server</a:t>
-            </a:r>
-            <a:endParaRPr lang="en-US" sz="1300" dirty="0"/>
+            <a:r>
+              <a:t>Internal LAN Data</a:t>
+            </a:r>
           </a:p>
         </p:txBody>
       </p:sp>
@@ -6470,21 +5789,9 @@
           <a:bodyPr wrap="square" lIns="0" tIns="0" rIns="0" bIns="0" rtlCol="0" anchor="t"/>
           <a:lstStyle/>
           <a:p>
-            <a:pPr algn="l" indent="0" marL="0">
-              <a:buNone/>
-            </a:pPr>
-            <a:r>
-              <a:rPr lang="en-US" sz="1050" dirty="0">
-                <a:solidFill>
-                  <a:srgbClr val="5F7388"/>
-                </a:solidFill>
-                <a:latin typeface="Calibri" pitchFamily="34" charset="0"/>
-                <a:ea typeface="Calibri" pitchFamily="34" charset="-122"/>
-                <a:cs typeface="Calibri" pitchFamily="34" charset="-120"/>
-              </a:rPr>
-              <a:t>One command starts a lightweight server. Non-technical users launch via BC_Dashboard_App.bat — one double-click.</a:t>
-            </a:r>
-            <a:endParaRPr lang="en-US" sz="1050" dirty="0"/>
+            <a:r>
+              <a:t>Look West, sector, and project datasets are maintained in LAN-based Excel files.</a:t>
+            </a:r>
           </a:p>
         </p:txBody>
       </p:sp>
@@ -6644,21 +5951,9 @@
           <a:bodyPr wrap="square" lIns="0" tIns="0" rIns="0" bIns="0" rtlCol="0" anchor="t"/>
           <a:lstStyle/>
           <a:p>
-            <a:pPr algn="l" indent="0" marL="0">
-              <a:buNone/>
-            </a:pPr>
-            <a:r>
-              <a:rPr lang="en-US" sz="1300" b="1" dirty="0">
-                <a:solidFill>
-                  <a:srgbClr val="1565A8"/>
-                </a:solidFill>
-                <a:latin typeface="Calibri" pitchFamily="34" charset="0"/>
-                <a:ea typeface="Calibri" pitchFamily="34" charset="-122"/>
-                <a:cs typeface="Calibri" pitchFamily="34" charset="-120"/>
-              </a:rPr>
-              <a:t>Live HTML Dashboards</a:t>
-            </a:r>
-            <a:endParaRPr lang="en-US" sz="1300" dirty="0"/>
+            <a:r>
+              <a:t>Communication Layer</a:t>
+            </a:r>
           </a:p>
         </p:txBody>
       </p:sp>
@@ -6683,21 +5978,9 @@
           <a:bodyPr wrap="square" lIns="0" tIns="0" rIns="0" bIns="0" rtlCol="0" anchor="t"/>
           <a:lstStyle/>
           <a:p>
-            <a:pPr algn="l" indent="0" marL="0">
-              <a:buNone/>
-            </a:pPr>
-            <a:r>
-              <a:rPr lang="en-US" sz="1050" dirty="0">
-                <a:solidFill>
-                  <a:srgbClr val="5F7388"/>
-                </a:solidFill>
-                <a:latin typeface="Calibri" pitchFamily="34" charset="0"/>
-                <a:ea typeface="Calibri" pitchFamily="34" charset="-122"/>
-                <a:cs typeface="Calibri" pitchFamily="34" charset="-120"/>
-              </a:rPr>
-              <a:t>Chart.js-powered interactive dashboards load in any browser — charts, filters, KPI cards all live and responsive.</a:t>
-            </a:r>
-            <a:endParaRPr lang="en-US" sz="1050" dirty="0"/>
+            <a:r>
+              <a:t>The dashboard standardizes, organizes, and structures analysis for effective internal communication.</a:t>
+            </a:r>
           </a:p>
         </p:txBody>
       </p:sp>
@@ -6749,21 +6032,9 @@
           <a:bodyPr wrap="square" lIns="0" tIns="0" rIns="0" bIns="0" rtlCol="0" anchor="ctr"/>
           <a:lstStyle/>
           <a:p>
-            <a:pPr algn="ctr" indent="0" marL="0">
-              <a:buNone/>
-            </a:pPr>
-            <a:r>
-              <a:rPr lang="en-US" sz="950" i="1" dirty="0">
-                <a:solidFill>
-                  <a:srgbClr val="0B4F8A"/>
-                </a:solidFill>
-                <a:latin typeface="Calibri" pitchFamily="34" charset="0"/>
-                <a:ea typeface="Calibri" pitchFamily="34" charset="-122"/>
-                <a:cs typeface="Calibri" pitchFamily="34" charset="-120"/>
-              </a:rPr>
-              <a:t>Packaged as BCLS_Dashboard_App.zip  ·  Installable on any Windows machine  ·  No cloud dependency  ·  No IT ticket required</a:t>
-            </a:r>
-            <a:endParaRPr lang="en-US" sz="950" dirty="0"/>
+            <a:r>
+              <a:t>Purpose: monitor BC economy and assess Look West progress with a consistent data storytelling framework.</a:t>
+            </a:r>
           </a:p>
         </p:txBody>
       </p:sp>
@@ -7079,21 +6350,9 @@
           <a:bodyPr wrap="square" lIns="0" tIns="0" rIns="0" bIns="0" rtlCol="0" anchor="t"/>
           <a:lstStyle/>
           <a:p>
-            <a:pPr algn="l" indent="0" marL="0">
-              <a:buNone/>
-            </a:pPr>
-            <a:r>
-              <a:rPr lang="en-US" sz="1150" dirty="0">
-                <a:solidFill>
-                  <a:srgbClr val="FFFFFF"/>
-                </a:solidFill>
-                <a:latin typeface="Calibri" pitchFamily="34" charset="0"/>
-                <a:ea typeface="Calibri" pitchFamily="34" charset="-122"/>
-                <a:cs typeface="Calibri" pitchFamily="34" charset="-120"/>
-              </a:rPr>
-              <a:t>One integrated platform supporting Look West Strategy tracking end-to-end — from media mentions to funding announcements to policy shifts. All in one place.</a:t>
-            </a:r>
-            <a:endParaRPr lang="en-US" sz="1150" dirty="0"/>
+            <a:r>
+              <a:t>One integrated internal platform to monitor BC economy and track Look West progress using API and LAN-managed data.</a:t>
+            </a:r>
           </a:p>
         </p:txBody>
       </p:sp>
@@ -7145,21 +6404,9 @@
           <a:bodyPr wrap="square" lIns="0" tIns="0" rIns="0" bIns="0" rtlCol="0" anchor="ctr"/>
           <a:lstStyle/>
           <a:p>
-            <a:pPr algn="ctr" indent="0" marL="0">
-              <a:buNone/>
-            </a:pPr>
-            <a:r>
-              <a:rPr lang="en-US" sz="950" b="1" dirty="0">
-                <a:solidFill>
-                  <a:srgbClr val="BDD7EE"/>
-                </a:solidFill>
-                <a:latin typeface="Calibri" pitchFamily="34" charset="0"/>
-                <a:ea typeface="Calibri" pitchFamily="34" charset="-122"/>
-                <a:cs typeface="Calibri" pitchFamily="34" charset="-120"/>
-              </a:rPr>
-              <a:t>Dashboard Hub</a:t>
-            </a:r>
-            <a:endParaRPr lang="en-US" sz="950" dirty="0"/>
+            <a:r>
+              <a:t>BC Insights Dashboard</a:t>
+            </a:r>
           </a:p>
         </p:txBody>
       </p:sp>
@@ -7211,21 +6458,9 @@
           <a:bodyPr wrap="square" lIns="0" tIns="0" rIns="0" bIns="0" rtlCol="0" anchor="ctr"/>
           <a:lstStyle/>
           <a:p>
-            <a:pPr algn="ctr" indent="0" marL="0">
-              <a:buNone/>
-            </a:pPr>
-            <a:r>
-              <a:rPr lang="en-US" sz="950" b="1" dirty="0">
-                <a:solidFill>
-                  <a:srgbClr val="BDD7EE"/>
-                </a:solidFill>
-                <a:latin typeface="Calibri" pitchFamily="34" charset="0"/>
-                <a:ea typeface="Calibri" pitchFamily="34" charset="-122"/>
-                <a:cs typeface="Calibri" pitchFamily="34" charset="-120"/>
-              </a:rPr>
-              <a:t>BC Macroeconomy</a:t>
-            </a:r>
-            <a:endParaRPr lang="en-US" sz="950" dirty="0"/>
+            <a:r>
+              <a:t>BC Economy Snapshot + BC Trade Analysis</a:t>
+            </a:r>
           </a:p>
         </p:txBody>
       </p:sp>
@@ -7277,21 +6512,9 @@
           <a:bodyPr wrap="square" lIns="0" tIns="0" rIns="0" bIns="0" rtlCol="0" anchor="ctr"/>
           <a:lstStyle/>
           <a:p>
-            <a:pPr algn="ctr" indent="0" marL="0">
-              <a:buNone/>
-            </a:pPr>
-            <a:r>
-              <a:rPr lang="en-US" sz="950" b="1" dirty="0">
-                <a:solidFill>
-                  <a:srgbClr val="BDD7EE"/>
-                </a:solidFill>
-                <a:latin typeface="Calibri" pitchFamily="34" charset="0"/>
-                <a:ea typeface="Calibri" pitchFamily="34" charset="-122"/>
-                <a:cs typeface="Calibri" pitchFamily="34" charset="-120"/>
-              </a:rPr>
-              <a:t>Look West Strategy</a:t>
-            </a:r>
-            <a:endParaRPr lang="en-US" sz="950" dirty="0"/>
+            <a:r>
+              <a:t>Look West Strategy: Overview, Sectors, Projects</a:t>
+            </a:r>
           </a:p>
         </p:txBody>
       </p:sp>
@@ -7343,21 +6566,9 @@
           <a:bodyPr wrap="square" lIns="0" tIns="0" rIns="0" bIns="0" rtlCol="0" anchor="ctr"/>
           <a:lstStyle/>
           <a:p>
-            <a:pPr algn="ctr" indent="0" marL="0">
-              <a:buNone/>
-            </a:pPr>
-            <a:r>
-              <a:rPr lang="en-US" sz="950" b="1" dirty="0">
-                <a:solidFill>
-                  <a:srgbClr val="BDD7EE"/>
-                </a:solidFill>
-                <a:latin typeface="Calibri" pitchFamily="34" charset="0"/>
-                <a:ea typeface="Calibri" pitchFamily="34" charset="-122"/>
-                <a:cs typeface="Calibri" pitchFamily="34" charset="-120"/>
-              </a:rPr>
-              <a:t>9 Sector Dashboards</a:t>
-            </a:r>
-            <a:endParaRPr lang="en-US" sz="950" dirty="0"/>
+            <a:r>
+              <a:t>Data from APIs + Internal LAN Files</a:t>
+            </a:r>
           </a:p>
         </p:txBody>
       </p:sp>
@@ -7382,21 +6593,9 @@
           <a:bodyPr wrap="square" lIns="0" tIns="0" rIns="0" bIns="0" rtlCol="0" anchor="ctr"/>
           <a:lstStyle/>
           <a:p>
-            <a:pPr algn="l" indent="0" marL="0">
-              <a:buNone/>
-            </a:pPr>
-            <a:r>
-              <a:rPr lang="en-US" sz="850" dirty="0">
-                <a:solidFill>
-                  <a:srgbClr val="5F7388"/>
-                </a:solidFill>
-                <a:latin typeface="Calibri" pitchFamily="34" charset="0"/>
-                <a:ea typeface="Calibri" pitchFamily="34" charset="-122"/>
-                <a:cs typeface="Calibri" pitchFamily="34" charset="-120"/>
-              </a:rPr>
-              <a:t>BC Dashboard Hub  ·  Ministry of Jobs and Economic Growth  ·  Economic Strategy Branch</a:t>
-            </a:r>
-            <a:endParaRPr lang="en-US" sz="850" dirty="0"/>
+            <a:r>
+              <a:t>BC Insights Dashboard  ·  Ministry of Jobs and Economic Growth  ·  Economic Strategy Branch</a:t>
+            </a:r>
           </a:p>
         </p:txBody>
       </p:sp>

</xml_diff>